<commit_message>
adding presentation and pdf
</commit_message>
<xml_diff>
--- a/NLP_Obituary_Presentation_v3.pptx
+++ b/NLP_Obituary_Presentation_v3.pptx
@@ -139,10 +139,33 @@
   <pc:docChgLst>
     <pc:chgData name="Mariajose Argote" userId="bca0b3a3594cbf72" providerId="LiveId" clId="{B774E549-DD53-4416-BE4B-E4BBF35CC248}"/>
     <pc:docChg chg="custSel modSld">
-      <pc:chgData name="Mariajose Argote" userId="bca0b3a3594cbf72" providerId="LiveId" clId="{B774E549-DD53-4416-BE4B-E4BBF35CC248}" dt="2026-03-17T21:47:09.975" v="1" actId="1076"/>
+      <pc:chgData name="Mariajose Argote" userId="bca0b3a3594cbf72" providerId="LiveId" clId="{B774E549-DD53-4416-BE4B-E4BBF35CC248}" dt="2026-03-17T21:51:34.095" v="3" actId="478"/>
       <pc:docMkLst>
         <pc:docMk/>
       </pc:docMkLst>
+      <pc:sldChg chg="delSp mod">
+        <pc:chgData name="Mariajose Argote" userId="bca0b3a3594cbf72" providerId="LiveId" clId="{B774E549-DD53-4416-BE4B-E4BBF35CC248}" dt="2026-03-17T21:51:34.095" v="3" actId="478"/>
+        <pc:sldMkLst>
+          <pc:docMk/>
+          <pc:sldMk cId="0" sldId="259"/>
+        </pc:sldMkLst>
+        <pc:spChg chg="del">
+          <ac:chgData name="Mariajose Argote" userId="bca0b3a3594cbf72" providerId="LiveId" clId="{B774E549-DD53-4416-BE4B-E4BBF35CC248}" dt="2026-03-17T21:51:31.699" v="2" actId="478"/>
+          <ac:spMkLst>
+            <pc:docMk/>
+            <pc:sldMk cId="0" sldId="259"/>
+            <ac:spMk id="17" creationId="{00000000-0000-0000-0000-000000000000}"/>
+          </ac:spMkLst>
+        </pc:spChg>
+        <pc:spChg chg="del">
+          <ac:chgData name="Mariajose Argote" userId="bca0b3a3594cbf72" providerId="LiveId" clId="{B774E549-DD53-4416-BE4B-E4BBF35CC248}" dt="2026-03-17T21:51:34.095" v="3" actId="478"/>
+          <ac:spMkLst>
+            <pc:docMk/>
+            <pc:sldMk cId="0" sldId="259"/>
+            <ac:spMk id="18" creationId="{00000000-0000-0000-0000-000000000000}"/>
+          </ac:spMkLst>
+        </pc:spChg>
+      </pc:sldChg>
       <pc:sldChg chg="delSp modSp mod">
         <pc:chgData name="Mariajose Argote" userId="bca0b3a3594cbf72" providerId="LiveId" clId="{B774E549-DD53-4416-BE4B-E4BBF35CC248}" dt="2026-03-17T21:47:09.975" v="1" actId="1076"/>
         <pc:sldMkLst>
@@ -12574,72 +12597,6 @@
                 <a:cs typeface="Montserrat" pitchFamily="34" charset="-120"/>
               </a:rPr>
               <a:t>TF-IDF vectors per year × gender</a:t>
-            </a:r>
-            <a:endParaRPr lang="en-US" sz="1100" dirty="0"/>
-          </a:p>
-        </p:txBody>
-      </p:sp>
-      <p:sp>
-        <p:nvSpPr>
-          <p:cNvPr id="17" name="Shape 15"/>
-          <p:cNvSpPr/>
-          <p:nvPr/>
-        </p:nvSpPr>
-        <p:spPr>
-          <a:xfrm>
-            <a:off x="640080" y="4434840"/>
-            <a:ext cx="7863840" cy="411480"/>
-          </a:xfrm>
-          <a:prstGeom prst="rect">
-            <a:avLst/>
-          </a:prstGeom>
-          <a:solidFill>
-            <a:srgbClr val="363B5E"/>
-          </a:solidFill>
-          <a:ln/>
-        </p:spPr>
-        <p:txBody>
-          <a:bodyPr/>
-          <a:lstStyle/>
-          <a:p>
-            <a:endParaRPr lang="en-US"/>
-          </a:p>
-        </p:txBody>
-      </p:sp>
-      <p:sp>
-        <p:nvSpPr>
-          <p:cNvPr id="18" name="Text 16"/>
-          <p:cNvSpPr/>
-          <p:nvPr/>
-        </p:nvSpPr>
-        <p:spPr>
-          <a:xfrm>
-            <a:off x="868680" y="4434840"/>
-            <a:ext cx="7406640" cy="411480"/>
-          </a:xfrm>
-          <a:prstGeom prst="rect">
-            <a:avLst/>
-          </a:prstGeom>
-          <a:noFill/>
-          <a:ln/>
-        </p:spPr>
-        <p:txBody>
-          <a:bodyPr wrap="square" lIns="0" tIns="0" rIns="0" bIns="0" rtlCol="0" anchor="ctr"/>
-          <a:lstStyle/>
-          <a:p>
-            <a:pPr marL="0" indent="0">
-              <a:buNone/>
-            </a:pPr>
-            <a:r>
-              <a:rPr lang="en-US" sz="1100" dirty="0">
-                <a:solidFill>
-                  <a:srgbClr val="F2D06B"/>
-                </a:solidFill>
-                <a:latin typeface="Montserrat" pitchFamily="34" charset="0"/>
-                <a:ea typeface="Montserrat" pitchFamily="34" charset="-122"/>
-                <a:cs typeface="Montserrat" pitchFamily="34" charset="-120"/>
-              </a:rPr>
-              <a:t>Key filter:  Minimum age 70 at death — ensures comparable life arcs</a:t>
             </a:r>
             <a:endParaRPr lang="en-US" sz="1100" dirty="0"/>
           </a:p>

</xml_diff>